<commit_message>
Stop the deck claiming PyTorch, and print the repository address
Slide 3 listed PyTorch in the stack. Nothing in this project imports
it: the detector heads are XGBoost, the rest is scikit-learn, NumPy,
Pandas and SciPy, and the evidence chain uses cryptography. A judge who
checked the dependency list against the slide would have found the
slide wrong, so the line now names what is actually installed and says
plainly that there is no neural network in the detection path.

Slide 6 ended on the literal text [REPO URL]. It now carries the
address, as a hyperlink and as readable text, so it survives being
printed or exported to PDF.

Brings this copy of the deck sources up to date with the one the
submission was built from, which adds the dataset hyperlinks and the
QR strip. Team ID on slide 1 is still a placeholder.
</commit_message>
<xml_diff>
--- a/submission/SIH2026_SIH26145_EKAGRA_idea.pptx
+++ b/submission/SIH2026_SIH26145_EKAGRA_idea.pptx
@@ -7992,7 +7992,7 @@
                 </a:solidFill>
                 <a:latin typeface="Calibri"/>
               </a:rPr>
-              <a:t>Stack  -  Python 3.12, XGBoost, NumPy/Pandas, PyTorch, pytest. No external service in the detection path, by design.</a:t>
+              <a:t>Stack  -  Python 3.12, XGBoost, scikit-learn, NumPy/Pandas, SciPy, cryptography, pytest. No neural network and no external service in the detection path, by design.</a:t>
             </a:r>
           </a:p>
         </p:txBody>
@@ -11348,7 +11348,7 @@
         <p:spPr bwMode="auto">
           <a:xfrm>
             <a:off x="612648" y="1188720"/>
-            <a:ext cx="10972800" cy="4937760"/>
+            <a:ext cx="10972800" cy="4069080"/>
           </a:xfrm>
           <a:prstGeom prst="rect">
             <a:avLst/>
@@ -11375,7 +11375,7 @@
                 <a:spcPts val="0"/>
               </a:spcBef>
               <a:spcAft>
-                <a:spcPts val="600"/>
+                <a:spcPts val="450"/>
               </a:spcAft>
               <a:buClrTx/>
               <a:buSzTx/>
@@ -11391,7 +11391,7 @@
                 </a:solidFill>
                 <a:latin typeface="Calibri"/>
               </a:rPr>
-              <a:t>Datasets</a:t>
+              <a:t>Datasets  -  addresses printed below, and scannable at the foot of this slide</a:t>
             </a:r>
             <a:endParaRPr kumimoji="0" lang="en-US" sz="2800" b="0" i="0" u="none" strike="noStrike" kern="1200" cap="none" spc="0" normalizeH="0" baseline="0" noProof="0" dirty="0">
               <a:ln>
@@ -11414,7 +11414,7 @@
                 <a:spcPts val="0"/>
               </a:spcBef>
               <a:spcAft>
-                <a:spcPts val="400"/>
+                <a:spcPts val="250"/>
               </a:spcAft>
             </a:pPr>
             <a:r>
@@ -11424,7 +11424,17 @@
                 </a:solidFill>
                 <a:latin typeface="Calibri"/>
               </a:rPr>
-              <a:t>Huang, Bois &amp; Marchioro - Corrected CICFlowMeter Datasets: CIC-IDS 2017. Zenodo 22016274 (CC-BY-4.0). Chosen over the original CSVs, which have documented label and feature-extractor defects.</a:t>
+              <a:t>Huang, Bois &amp; Marchioro - Corrected CICFlowMeter Datasets: CIC-IDS 2017. Zenodo 22016274 (CC-BY-4.0). 877,801 flows, the corpus every measured number on these slides comes from. Chosen over the original CSVs, which have documented label and feature-extractor defects.</a:t>
+            </a:r>
+            <a:r>
+              <a:rPr sz="1050" b="0" u="sng">
+                <a:solidFill>
+                  <a:srgbClr val="0B6B63"/>
+                </a:solidFill>
+                <a:latin typeface="Calibri"/>
+                <a:hlinkClick r:id="rId4"/>
+              </a:rPr>
+              <a:t>  zenodo.org/records/22016274</a:t>
             </a:r>
           </a:p>
           <a:p>
@@ -11433,7 +11443,7 @@
                 <a:spcPts val="0"/>
               </a:spcBef>
               <a:spcAft>
-                <a:spcPts val="400"/>
+                <a:spcPts val="250"/>
               </a:spcAft>
             </a:pPr>
             <a:r>
@@ -11443,7 +11453,65 @@
                 </a:solidFill>
                 <a:latin typeface="Calibri"/>
               </a:rPr>
-              <a:t>Engelen, Rimmer &amp; Joosen - Troubleshooting an Intrusion Detection Dataset: the CICIDS2017 case study. IEEE S&amp;P Workshops, 2021.</a:t>
+              <a:t>Source corpus it re-extracts - CIC-IDS2017, Canadian Institute for Cybersecurity, University of New Brunswick.</a:t>
+            </a:r>
+            <a:r>
+              <a:rPr sz="1050" b="0" u="sng">
+                <a:solidFill>
+                  <a:srgbClr val="0B6B63"/>
+                </a:solidFill>
+                <a:latin typeface="Calibri"/>
+                <a:hlinkClick r:id="rId5"/>
+              </a:rPr>
+              <a:t>  unb.ca/cic/datasets/ids-2017.html</a:t>
+            </a:r>
+          </a:p>
+          <a:p>
+            <a:pPr algn="l">
+              <a:spcBef>
+                <a:spcPts val="0"/>
+              </a:spcBef>
+              <a:spcAft>
+                <a:spcPts val="250"/>
+              </a:spcAft>
+            </a:pPr>
+            <a:r>
+              <a:rPr sz="1150" b="0">
+                <a:solidFill>
+                  <a:srgbClr val="141918"/>
+                </a:solidFill>
+                <a:latin typeface="Calibri"/>
+              </a:rPr>
+              <a:t>Engelen, Rimmer &amp; Joosen - Troubleshooting an Intrusion Detection Dataset: the CICIDS2017 case study. IEEE S&amp;P Workshops, 2021. Why we use the corrected re-extraction.</a:t>
+            </a:r>
+            <a:r>
+              <a:rPr sz="1050" b="0" u="sng">
+                <a:solidFill>
+                  <a:srgbClr val="0B6B63"/>
+                </a:solidFill>
+                <a:latin typeface="Calibri"/>
+                <a:hlinkClick r:id="rId6"/>
+              </a:rPr>
+              <a:t>  doi.org/10.1109/SPW53761.2021.00009</a:t>
+            </a:r>
+          </a:p>
+          <a:p>
+            <a:pPr algn="l">
+              <a:spcBef>
+                <a:spcPts val="0"/>
+              </a:spcBef>
+              <a:spcAft>
+                <a:spcPts val="250"/>
+              </a:spcAft>
+            </a:pPr>
+            <a:r>
+              <a:rPr sz="1150" b="0">
+                <a:solidFill>
+                  <a:srgbClr val="141918"/>
+                </a:solidFill>
+                <a:latin typeface="Calibri"/>
+              </a:rPr>
+              <a:t>Our own capture - 147 MB, 6 minutes of ordinary browsing, 148,416 packets. Not redistributable (personal traffic); the TLS, JA4 and QUIC findings come from it and reproduce on any capture.</a:t>
             </a:r>
           </a:p>
           <a:p>
@@ -11452,7 +11520,7 @@
                 <a:spcPts val="800"/>
               </a:spcBef>
               <a:spcAft>
-                <a:spcPts val="600"/>
+                <a:spcPts val="450"/>
               </a:spcAft>
             </a:pPr>
             <a:r>
@@ -11471,7 +11539,7 @@
                 <a:spcPts val="0"/>
               </a:spcBef>
               <a:spcAft>
-                <a:spcPts val="400"/>
+                <a:spcPts val="250"/>
               </a:spcAft>
             </a:pPr>
             <a:r>
@@ -11490,7 +11558,7 @@
                 <a:spcPts val="0"/>
               </a:spcBef>
               <a:spcAft>
-                <a:spcPts val="400"/>
+                <a:spcPts val="250"/>
               </a:spcAft>
             </a:pPr>
             <a:r>
@@ -11509,7 +11577,7 @@
                 <a:spcPts val="0"/>
               </a:spcBef>
               <a:spcAft>
-                <a:spcPts val="400"/>
+                <a:spcPts val="250"/>
               </a:spcAft>
             </a:pPr>
             <a:r>
@@ -11528,7 +11596,7 @@
                 <a:spcPts val="800"/>
               </a:spcBef>
               <a:spcAft>
-                <a:spcPts val="600"/>
+                <a:spcPts val="450"/>
               </a:spcAft>
             </a:pPr>
             <a:r>
@@ -11547,7 +11615,7 @@
                 <a:spcPts val="0"/>
               </a:spcBef>
               <a:spcAft>
-                <a:spcPts val="400"/>
+                <a:spcPts val="250"/>
               </a:spcAft>
             </a:pPr>
             <a:r>
@@ -11566,7 +11634,7 @@
                 <a:spcPts val="800"/>
               </a:spcBef>
               <a:spcAft>
-                <a:spcPts val="600"/>
+                <a:spcPts val="450"/>
               </a:spcAft>
             </a:pPr>
             <a:r>
@@ -11585,7 +11653,7 @@
                 <a:spcPts val="0"/>
               </a:spcBef>
               <a:spcAft>
-                <a:spcPts val="400"/>
+                <a:spcPts val="250"/>
               </a:spcAft>
             </a:pPr>
             <a:r>
@@ -11595,7 +11663,17 @@
                 </a:solidFill>
                 <a:latin typeface="Calibri"/>
               </a:rPr>
-              <a:t>Repository with all experiments, pre-registered predictions and verdicts, and one-command reproduction: [REPO URL]</a:t>
+              <a:t>Repository with all experiments, pre-registered predictions and verdicts, and one-command reproduction:</a:t>
+            </a:r>
+            <a:r>
+              <a:rPr sz="1050" b="0" u="sng">
+                <a:solidFill>
+                  <a:srgbClr val="0B6B63"/>
+                </a:solidFill>
+                <a:latin typeface="Calibri"/>
+                <a:hlinkClick r:id="rId7"/>
+              </a:rPr>
+              <a:t>  github.com/AKRai-2005/ekagra</a:t>
             </a:r>
           </a:p>
         </p:txBody>
@@ -11835,6 +11913,376 @@
           </a:prstGeom>
         </p:spPr>
       </p:pic>
+      <p:sp>
+        <p:nvSpPr>
+          <p:cNvPr id="17411" name="Rounded Rectangle 17410"/>
+          <p:cNvSpPr/>
+          <p:nvPr/>
+        </p:nvSpPr>
+        <p:spPr>
+          <a:xfrm>
+            <a:off x="612648" y="5340096"/>
+            <a:ext cx="10972800" cy="960120"/>
+          </a:xfrm>
+          <a:prstGeom prst="roundRect">
+            <a:avLst/>
+          </a:prstGeom>
+          <a:solidFill>
+            <a:srgbClr val="F4F7F6"/>
+          </a:solidFill>
+          <a:ln>
+            <a:noFill/>
+          </a:ln>
+          <a:effectLst/>
+        </p:spPr>
+        <p:style>
+          <a:lnRef idx="1">
+            <a:schemeClr val="accent1"/>
+          </a:lnRef>
+          <a:fillRef idx="3">
+            <a:schemeClr val="accent1"/>
+          </a:fillRef>
+          <a:effectRef idx="2">
+            <a:schemeClr val="accent1"/>
+          </a:effectRef>
+          <a:fontRef idx="minor">
+            <a:schemeClr val="lt1"/>
+          </a:fontRef>
+        </p:style>
+        <p:txBody>
+          <a:bodyPr rtlCol="0" anchor="ctr" wrap="square" lIns="54864" rIns="54864" tIns="27432" bIns="27432"/>
+          <a:lstStyle/>
+          <a:p>
+            <a:pPr algn="l"/>
+            <a:r>
+              <a:rPr sz="1100" b="0">
+                <a:solidFill>
+                  <a:srgbClr val="141918"/>
+                </a:solidFill>
+                <a:latin typeface="Calibri"/>
+              </a:rPr>
+              <a:t/>
+            </a:r>
+          </a:p>
+        </p:txBody>
+      </p:sp>
+      <p:sp>
+        <p:nvSpPr>
+          <p:cNvPr id="17412" name="TextBox 17411"/>
+          <p:cNvSpPr txBox="1"/>
+          <p:nvPr/>
+        </p:nvSpPr>
+        <p:spPr>
+          <a:xfrm>
+            <a:off x="731520" y="5367528"/>
+            <a:ext cx="5486400" cy="182880"/>
+          </a:xfrm>
+          <a:prstGeom prst="rect">
+            <a:avLst/>
+          </a:prstGeom>
+          <a:noFill/>
+        </p:spPr>
+        <p:txBody>
+          <a:bodyPr wrap="square" lIns="0" rIns="0" tIns="0" bIns="0">
+            <a:spAutoFit/>
+          </a:bodyPr>
+          <a:lstStyle/>
+          <a:p>
+            <a:pPr algn="l"/>
+            <a:r>
+              <a:rPr sz="800" b="1">
+                <a:solidFill>
+                  <a:srgbClr val="0B6B63"/>
+                </a:solidFill>
+                <a:latin typeface="Calibri"/>
+              </a:rPr>
+              <a:t>SCAN OR TYPE  -  the datasets, reachable from any device</a:t>
+            </a:r>
+          </a:p>
+        </p:txBody>
+      </p:sp>
+      <p:pic>
+        <p:nvPicPr>
+          <p:cNvPr id="17413" name="Picture 17412" descr="qr_3c73e79a8586.png"/>
+          <p:cNvPicPr>
+            <a:picLocks noChangeAspect="1"/>
+          </p:cNvPicPr>
+          <p:nvPr/>
+        </p:nvPicPr>
+        <p:blipFill>
+          <a:blip r:embed="rId8"/>
+          <a:stretch>
+            <a:fillRect/>
+          </a:stretch>
+        </p:blipFill>
+        <p:spPr>
+          <a:xfrm>
+            <a:off x="731520" y="5541264"/>
+            <a:ext cx="713232" cy="713232"/>
+          </a:xfrm>
+          <a:prstGeom prst="rect">
+            <a:avLst/>
+          </a:prstGeom>
+        </p:spPr>
+      </p:pic>
+      <p:sp>
+        <p:nvSpPr>
+          <p:cNvPr id="17414" name="TextBox 17413"/>
+          <p:cNvSpPr txBox="1"/>
+          <p:nvPr/>
+        </p:nvSpPr>
+        <p:spPr>
+          <a:xfrm>
+            <a:off x="1536192" y="5577840"/>
+            <a:ext cx="2743200" cy="201168"/>
+          </a:xfrm>
+          <a:prstGeom prst="rect">
+            <a:avLst/>
+          </a:prstGeom>
+          <a:noFill/>
+        </p:spPr>
+        <p:txBody>
+          <a:bodyPr wrap="square" lIns="0" rIns="0" tIns="0" bIns="0">
+            <a:spAutoFit/>
+          </a:bodyPr>
+          <a:lstStyle/>
+          <a:p>
+            <a:pPr algn="l"/>
+            <a:r>
+              <a:rPr sz="900" b="1">
+                <a:solidFill>
+                  <a:srgbClr val="141918"/>
+                </a:solidFill>
+                <a:latin typeface="Calibri"/>
+              </a:rPr>
+              <a:t>Corrected CIC-IDS2017 (the one we used)</a:t>
+            </a:r>
+          </a:p>
+        </p:txBody>
+      </p:sp>
+      <p:sp>
+        <p:nvSpPr>
+          <p:cNvPr id="17415" name="TextBox 17414"/>
+          <p:cNvSpPr txBox="1"/>
+          <p:nvPr/>
+        </p:nvSpPr>
+        <p:spPr>
+          <a:xfrm>
+            <a:off x="1536192" y="5797296"/>
+            <a:ext cx="2743200" cy="365760"/>
+          </a:xfrm>
+          <a:prstGeom prst="rect">
+            <a:avLst/>
+          </a:prstGeom>
+          <a:noFill/>
+        </p:spPr>
+        <p:txBody>
+          <a:bodyPr wrap="square" lIns="0" rIns="0" tIns="0" bIns="0">
+            <a:spAutoFit/>
+          </a:bodyPr>
+          <a:lstStyle/>
+          <a:p>
+            <a:pPr algn="l"/>
+            <a:r>
+              <a:rPr sz="800" b="0">
+                <a:solidFill>
+                  <a:srgbClr val="55605D"/>
+                </a:solidFill>
+                <a:latin typeface="Calibri"/>
+              </a:rPr>
+              <a:t>zenodo.org/records/22016274</a:t>
+            </a:r>
+          </a:p>
+        </p:txBody>
+      </p:sp>
+      <p:pic>
+        <p:nvPicPr>
+          <p:cNvPr id="17416" name="Picture 17415" descr="qr_bee78d23fcf0.png"/>
+          <p:cNvPicPr>
+            <a:picLocks noChangeAspect="1"/>
+          </p:cNvPicPr>
+          <p:nvPr/>
+        </p:nvPicPr>
+        <p:blipFill>
+          <a:blip r:embed="rId9"/>
+          <a:stretch>
+            <a:fillRect/>
+          </a:stretch>
+        </p:blipFill>
+        <p:spPr>
+          <a:xfrm>
+            <a:off x="4343400" y="5541264"/>
+            <a:ext cx="713232" cy="713232"/>
+          </a:xfrm>
+          <a:prstGeom prst="rect">
+            <a:avLst/>
+          </a:prstGeom>
+        </p:spPr>
+      </p:pic>
+      <p:sp>
+        <p:nvSpPr>
+          <p:cNvPr id="17417" name="TextBox 17416"/>
+          <p:cNvSpPr txBox="1"/>
+          <p:nvPr/>
+        </p:nvSpPr>
+        <p:spPr>
+          <a:xfrm>
+            <a:off x="5148072" y="5577840"/>
+            <a:ext cx="2743200" cy="201168"/>
+          </a:xfrm>
+          <a:prstGeom prst="rect">
+            <a:avLst/>
+          </a:prstGeom>
+          <a:noFill/>
+        </p:spPr>
+        <p:txBody>
+          <a:bodyPr wrap="square" lIns="0" rIns="0" tIns="0" bIns="0">
+            <a:spAutoFit/>
+          </a:bodyPr>
+          <a:lstStyle/>
+          <a:p>
+            <a:pPr algn="l"/>
+            <a:r>
+              <a:rPr sz="900" b="1">
+                <a:solidFill>
+                  <a:srgbClr val="141918"/>
+                </a:solidFill>
+                <a:latin typeface="Calibri"/>
+              </a:rPr>
+              <a:t>Original CIC-IDS2017 (UNB CIC)</a:t>
+            </a:r>
+          </a:p>
+        </p:txBody>
+      </p:sp>
+      <p:sp>
+        <p:nvSpPr>
+          <p:cNvPr id="17418" name="TextBox 17417"/>
+          <p:cNvSpPr txBox="1"/>
+          <p:nvPr/>
+        </p:nvSpPr>
+        <p:spPr>
+          <a:xfrm>
+            <a:off x="5148072" y="5797296"/>
+            <a:ext cx="2743200" cy="365760"/>
+          </a:xfrm>
+          <a:prstGeom prst="rect">
+            <a:avLst/>
+          </a:prstGeom>
+          <a:noFill/>
+        </p:spPr>
+        <p:txBody>
+          <a:bodyPr wrap="square" lIns="0" rIns="0" tIns="0" bIns="0">
+            <a:spAutoFit/>
+          </a:bodyPr>
+          <a:lstStyle/>
+          <a:p>
+            <a:pPr algn="l"/>
+            <a:r>
+              <a:rPr sz="800" b="0">
+                <a:solidFill>
+                  <a:srgbClr val="55605D"/>
+                </a:solidFill>
+                <a:latin typeface="Calibri"/>
+              </a:rPr>
+              <a:t>unb.ca/cic/datasets/ids-2017.html</a:t>
+            </a:r>
+          </a:p>
+        </p:txBody>
+      </p:sp>
+      <p:pic>
+        <p:nvPicPr>
+          <p:cNvPr id="17419" name="Picture 17418" descr="qr_6d3531976914.png"/>
+          <p:cNvPicPr>
+            <a:picLocks noChangeAspect="1"/>
+          </p:cNvPicPr>
+          <p:nvPr/>
+        </p:nvPicPr>
+        <p:blipFill>
+          <a:blip r:embed="rId10"/>
+          <a:stretch>
+            <a:fillRect/>
+          </a:stretch>
+        </p:blipFill>
+        <p:spPr>
+          <a:xfrm>
+            <a:off x="7955280" y="5541264"/>
+            <a:ext cx="713232" cy="713232"/>
+          </a:xfrm>
+          <a:prstGeom prst="rect">
+            <a:avLst/>
+          </a:prstGeom>
+        </p:spPr>
+      </p:pic>
+      <p:sp>
+        <p:nvSpPr>
+          <p:cNvPr id="17420" name="TextBox 17419"/>
+          <p:cNvSpPr txBox="1"/>
+          <p:nvPr/>
+        </p:nvSpPr>
+        <p:spPr>
+          <a:xfrm>
+            <a:off x="8759952" y="5577840"/>
+            <a:ext cx="2743200" cy="201168"/>
+          </a:xfrm>
+          <a:prstGeom prst="rect">
+            <a:avLst/>
+          </a:prstGeom>
+          <a:noFill/>
+        </p:spPr>
+        <p:txBody>
+          <a:bodyPr wrap="square" lIns="0" rIns="0" tIns="0" bIns="0">
+            <a:spAutoFit/>
+          </a:bodyPr>
+          <a:lstStyle/>
+          <a:p>
+            <a:pPr algn="l"/>
+            <a:r>
+              <a:rPr sz="900" b="1">
+                <a:solidFill>
+                  <a:srgbClr val="141918"/>
+                </a:solidFill>
+                <a:latin typeface="Calibri"/>
+              </a:rPr>
+              <a:t>Why the corrected one (Engelen 2021)</a:t>
+            </a:r>
+          </a:p>
+        </p:txBody>
+      </p:sp>
+      <p:sp>
+        <p:nvSpPr>
+          <p:cNvPr id="17421" name="TextBox 17420"/>
+          <p:cNvSpPr txBox="1"/>
+          <p:nvPr/>
+        </p:nvSpPr>
+        <p:spPr>
+          <a:xfrm>
+            <a:off x="8759952" y="5797296"/>
+            <a:ext cx="2743200" cy="365760"/>
+          </a:xfrm>
+          <a:prstGeom prst="rect">
+            <a:avLst/>
+          </a:prstGeom>
+          <a:noFill/>
+        </p:spPr>
+        <p:txBody>
+          <a:bodyPr wrap="square" lIns="0" rIns="0" tIns="0" bIns="0">
+            <a:spAutoFit/>
+          </a:bodyPr>
+          <a:lstStyle/>
+          <a:p>
+            <a:pPr algn="l"/>
+            <a:r>
+              <a:rPr sz="800" b="0">
+                <a:solidFill>
+                  <a:srgbClr val="55605D"/>
+                </a:solidFill>
+                <a:latin typeface="Calibri"/>
+              </a:rPr>
+              <a:t>doi.org/10.1109/SPW53761.2021.00009</a:t>
+            </a:r>
+          </a:p>
+        </p:txBody>
+      </p:sp>
     </p:spTree>
     <p:extLst>
       <p:ext uri="{BB962C8B-B14F-4D97-AF65-F5344CB8AC3E}">

</xml_diff>